<commit_message>
more formal midterm script, add pdf, sync notes in both pptx
</commit_message>
<xml_diff>
--- a/CIS4930_GROUP1.pptx
+++ b/CIS4930_GROUP1.pptx
@@ -304,49 +304,25 @@
           <a:p>
             <a:r>
               <a:rPr lang="en-US" dirty="0"/>
-              <a:t>Box 1. The decision (about 40 seconds)</a:t>
-            </a:r>
-          </a:p>
-          <a:p>
-            <a:r>
-              <a:rPr lang="en-US" dirty="0"/>
-              <a:t>- Our project asks whether learned indexes (LURN-d IN-deks-iz) still outperform traditional indexes on modern hardware.</a:t>
-            </a:r>
-          </a:p>
-          <a:p>
-            <a:r>
-              <a:rPr lang="en-US" dirty="0"/>
-              <a:t>- Every database lookup must decide where a key is stored in a sorted array. Today, a B+tree (bee-plus tree) makes this decision through a sequence of comparisons.</a:t>
-            </a:r>
-          </a:p>
-          <a:p>
-            <a:r>
-              <a:rPr lang="en-US" dirty="0"/>
-              <a:t>- A poor decision does not return an incorrect result. However, it costs additional cache misses, and each miss to main memory costs approximately one hundred nanoseconds (NAN-oh-sek-unds).</a:t>
-            </a:r>
-          </a:p>
-          <a:p>
-            <a:r>
-              <a:rPr lang="en-US" dirty="0"/>
               <a:t/>
             </a:r>
           </a:p>
           <a:p>
             <a:r>
               <a:rPr lang="en-US" dirty="0"/>
-              <a:t>Box 2. The baseline (about 30 seconds)</a:t>
-            </a:r>
-          </a:p>
-          <a:p>
-            <a:r>
-              <a:rPr lang="en-US" dirty="0"/>
-              <a:t>- Our first baseline is binary search over the sorted array, using the standard library function lower_bound (LOH-er bound) with full compiler optimization. This is the reference baseline in the SOSD (ess-oh-ess-dee) benchmark.</a:t>
-            </a:r>
-          </a:p>
-          <a:p>
-            <a:r>
-              <a:rPr lang="en-US" dirty="0"/>
-              <a:t>- On our test machine, binary search requires 525 nanoseconds per lookup at one hundred million keys. A tuned B+tree and a hash table will be added as further baselines in the next phase.</a:t>
+              <a:t>Box 1. The decision (0:30)</a:t>
+            </a:r>
+          </a:p>
+          <a:p>
+            <a:r>
+              <a:rPr lang="en-US" dirty="0"/>
+              <a:t>- Hello, everyone. We are Team 1, and our project examines whether learned indexes still outperform traditional index structures on modern hardware.</a:t>
+            </a:r>
+          </a:p>
+          <a:p>
+            <a:r>
+              <a:rPr lang="en-US" dirty="0"/>
+              <a:t>- Every database lookup must determine where a key is stored within a sorted array. Today, this decision is typically made by a B+tree, which moves from the root to a leaf through a sequence of comparisons. An imprecise step never produces an incorrect result, but each additional step can cause a cache miss, which costs roughly one hundred nanoseconds.</a:t>
             </a:r>
           </a:p>
           <a:p>
@@ -358,25 +334,13 @@
           <a:p>
             <a:r>
               <a:rPr lang="en-US" dirty="0"/>
-              <a:t>Box 3. Our approach (about 40 seconds)</a:t>
-            </a:r>
-          </a:p>
-          <a:p>
-            <a:r>
-              <a:rPr lang="en-US" dirty="0"/>
-              <a:t>- A learned index replaces the tree with a model that predicts the position of a key. We will evaluate four designs: the Recursive Model Index, or RMI (ar-em-eye), the PGM-index (pee-jee-em), RadixSpline (RAY-diks-spline), and ALEX (AL-eks).</a:t>
-            </a:r>
-          </a:p>
-          <a:p>
-            <a:r>
-              <a:rPr lang="en-US" dirty="0"/>
-              <a:t>- The training labels are free, because they are simply the positions of the keys in the sorted array.</a:t>
-            </a:r>
-          </a:p>
-          <a:p>
-            <a:r>
-              <a:rPr lang="en-US" dirty="0"/>
-              <a:t>- One inference costs a few multiply-add operations, followed by a local search inside a stored error bound. The result is therefore always exact.</a:t>
+              <a:t>Box 2. Beat what, exactly? (0:25)</a:t>
+            </a:r>
+          </a:p>
+          <a:p>
+            <a:r>
+              <a:rPr lang="en-US" dirty="0"/>
+              <a:t>- Our baseline is binary search over the sorted array, which is the reference baseline in the SOSD benchmark. On our test machine, it requires 525 nanoseconds per lookup at one hundred million keys. A tuned B+tree will be added as a stronger baseline in the next phase.</a:t>
             </a:r>
           </a:p>
           <a:p>
@@ -388,37 +352,19 @@
           <a:p>
             <a:r>
               <a:rPr lang="en-US" dirty="0"/>
-              <a:t>Box 4. First result (about 90 seconds)</a:t>
-            </a:r>
-          </a:p>
-          <a:p>
-            <a:r>
-              <a:rPr lang="en-US" dirty="0"/>
-              <a:t>- For the first result, we implemented a two-stage linear RMI, following Kraska (KRAS-kah) and colleagues. We compared it with binary search on two synthetic key distributions, uniform and lognormal (log-NOR-mul), from one hundred thousand to one hundred million keys.</a:t>
-            </a:r>
-          </a:p>
-          <a:p>
-            <a:r>
-              <a:rPr lang="en-US" dirty="0"/>
-              <a:t>- The horizontal axis shows the number of keys on a logarithmic (log-uh-RITH-mik) scale, and the vertical axis shows the median lookup latency. The dashed lines are the binary search baseline. The solid lines are the RMI, using the best of four model sizes at each point.</a:t>
-            </a:r>
-          </a:p>
-          <a:p>
-            <a:r>
-              <a:rPr lang="en-US" dirty="0"/>
-              <a:t>- Binary search slows down sharply once the data exceeds the 16-megabyte L3 (el-three) cache, because each lookup must then wait on main memory several times.</a:t>
-            </a:r>
-          </a:p>
-          <a:p>
-            <a:r>
-              <a:rPr lang="en-US" dirty="0"/>
-              <a:t>- The RMI remains much flatter. At one hundred million uniform keys, it reduces the lookup time from 525 to 81 nanoseconds, a speedup of approximately 6.5 times, with a model of only 2.3 megabytes.</a:t>
-            </a:r>
-          </a:p>
-          <a:p>
-            <a:r>
-              <a:rPr lang="en-US" dirty="0"/>
-              <a:t>- All measurements were taken on an AMD Ryzen (RY-zen) AI 7 350 laptop processor, with the thread pinned to a single core. Each point is the median of five runs of two million random lookups, after one warm-up run.</a:t>
+              <a:t>Box 3. Our approach (0:35)</a:t>
+            </a:r>
+          </a:p>
+          <a:p>
+            <a:r>
+              <a:rPr lang="en-US" dirty="0"/>
+              <a:t>- A learned index replaces the tree with a model that predicts the position of a key. We will evaluate four designs: the Recursive Model Index, or RMI, the PGM-index, RadixSpline, and ALEX, which also supports inserts.</a:t>
+            </a:r>
+          </a:p>
+          <a:p>
+            <a:r>
+              <a:rPr lang="en-US" dirty="0"/>
+              <a:t>- Training labels are available at no cost, since they are simply the positions of the keys. Each model also records its maximum prediction error, so a lookup requires one prediction followed by a search within a small, bounded window. The result is therefore always exact.</a:t>
             </a:r>
           </a:p>
           <a:p>
@@ -430,31 +376,37 @@
           <a:p>
             <a:r>
               <a:rPr lang="en-US" dirty="0"/>
-              <a:t>Box 5. What surprised us (about 90 seconds)</a:t>
-            </a:r>
-          </a:p>
-          <a:p>
-            <a:r>
-              <a:rPr lang="en-US" dirty="0"/>
-              <a:t>- The most important observation concerns the key distribution. With the same 2.3-megabyte model at one hundred million keys, lognormal lookups required 226 nanoseconds, compared with 81 nanoseconds for uniform keys.</a:t>
-            </a:r>
-          </a:p>
-          <a:p>
-            <a:r>
-              <a:rPr lang="en-US" dirty="0"/>
-              <a:t>- With a very small model of 58 kilobytes at ten million keys, the RMI was in fact slower than binary search, at 341 compared with 314 nanoseconds. A linear model cannot follow a skewed distribution, so the error window, and therefore the local search, becomes large.</a:t>
-            </a:r>
-          </a:p>
-          <a:p>
-            <a:r>
-              <a:rPr lang="en-US" dirty="0"/>
-              <a:t>- This taught us that results on uniform data overstate the benefit. The real datasets in SOSD, and the PGM-index and RadixSpline, which adapt better to skew, are therefore central to the next phase.</a:t>
-            </a:r>
-          </a:p>
-          <a:p>
-            <a:r>
-              <a:rPr lang="en-US" dirty="0"/>
-              <a:t>- We also encountered a measurement problem. This processor combines two types of cores. Without pinning the thread to one core, the results were about ten percent slower and considerably noisier. We now pin every run, add a warm-up period, and report the spread.</a:t>
+              <a:t>Box 4. First result (1:20)</a:t>
+            </a:r>
+          </a:p>
+          <a:p>
+            <a:r>
+              <a:rPr lang="en-US" dirty="0"/>
+              <a:t>- For our first result, we implemented a two-stage RMI and compared it with binary search on uniform and lognormal key distributions, ranging from one hundred thousand to one hundred million keys.</a:t>
+            </a:r>
+          </a:p>
+          <a:p>
+            <a:r>
+              <a:rPr lang="en-US" dirty="0"/>
+              <a:t>- [Point to the axes.] The horizontal axis shows the number of keys, and the vertical axis shows the median time per lookup. The dashed lines represent binary search, and the solid lines represent the learned index.</a:t>
+            </a:r>
+          </a:p>
+          <a:p>
+            <a:r>
+              <a:rPr lang="en-US" dirty="0"/>
+              <a:t>- [Point to the dotted line.] Beyond this line, the data no longer fits in the 16-megabyte L3 cache. Binary search must then wait on main memory several times per lookup, and its latency rises sharply.</a:t>
+            </a:r>
+          </a:p>
+          <a:p>
+            <a:r>
+              <a:rPr lang="en-US" dirty="0"/>
+              <a:t>- [Point to the solid black line.] The learned index remains nearly flat. At one hundred million keys, it reduces the lookup time from 525 to 81 nanoseconds. This is a speedup of approximately 6.5 times, with a model of only 2.3 megabytes.</a:t>
+            </a:r>
+          </a:p>
+          <a:p>
+            <a:r>
+              <a:rPr lang="en-US" dirty="0"/>
+              <a:t>- These measurements were taken on an AMD Ryzen AI 7 350 laptop processor. Each point is the median of five runs of two million random lookups, following a warm-up run.</a:t>
             </a:r>
           </a:p>
           <a:p>
@@ -466,19 +418,25 @@
           <a:p>
             <a:r>
               <a:rPr lang="en-US" dirty="0"/>
-              <a:t>Box 6. Next six weeks (about 40 seconds)</a:t>
-            </a:r>
-          </a:p>
-          <a:p>
-            <a:r>
-              <a:rPr lang="en-US" dirty="0"/>
-              <a:t>- The experiment that decides the project is the full SOSD benchmark on four real datasets, with hardware performance counters, on AMD, Intel, and ARM processors.</a:t>
-            </a:r>
-          </a:p>
-          <a:p>
-            <a:r>
-              <a:rPr lang="en-US" dirty="0"/>
-              <a:t>- The main risk is access to these counters. The Linux perf (purf) tool generally cannot read hardware counters inside WSL2 (dub-ul-yoo ess el two), and it does not exist on macOS. Our fallback is to rent bare-metal (bair-MET-ul) cloud instances on AWS for these runs.</a:t>
+              <a:t>Box 5. What surprised us (1:00)</a:t>
+            </a:r>
+          </a:p>
+          <a:p>
+            <a:r>
+              <a:rPr lang="en-US" dirty="0"/>
+              <a:t>- The most significant finding concerns the key distribution. With the same model size, lookups on lognormal keys required 226 nanoseconds, compared with 81 nanoseconds on uniform keys. With a very small model, the learned index was even slower than binary search.</a:t>
+            </a:r>
+          </a:p>
+          <a:p>
+            <a:r>
+              <a:rPr lang="en-US" dirty="0"/>
+              <a:t>- A simple linear model cannot capture a skewed distribution, so its error window, and therefore its search cost, grows. This indicates that results on uniform data overstate the benefit of learned indexes.</a:t>
+            </a:r>
+          </a:p>
+          <a:p>
+            <a:r>
+              <a:rPr lang="en-US" dirty="0"/>
+              <a:t>- We also observed that this processor combines two types of cores. Without pinning the benchmark to a single core, the results were approximately ten percent slower and considerably less stable.</a:t>
             </a:r>
           </a:p>
           <a:p>
@@ -490,19 +448,13 @@
           <a:p>
             <a:r>
               <a:rPr lang="en-US" dirty="0"/>
-              <a:t>Gate check (about 20 seconds)</a:t>
-            </a:r>
-          </a:p>
-          <a:p>
-            <a:r>
-              <a:rPr lang="en-US" dirty="0"/>
-              <a:t>- A wrong prediction is safe, because the search is bounded, and the labels are free. The model also fits the budget, at about 0.3 percent of the data size.</a:t>
-            </a:r>
-          </a:p>
-          <a:p>
-            <a:r>
-              <a:rPr lang="en-US" dirty="0"/>
-              <a:t>- We are unsure whether we beat a tuned baseline, because the B+tree is not yet integrated. We are also unsure about new workloads, because inserts have not been tested yet.</a:t>
+              <a:t>Box 6. Next six weeks (0:30)</a:t>
+            </a:r>
+          </a:p>
+          <a:p>
+            <a:r>
+              <a:rPr lang="en-US" dirty="0"/>
+              <a:t>- Over the next six weeks, the decisive experiment is the full SOSD benchmark on four real-world datasets, with hardware performance counters, on AMD, Intel, and ARM processors. The principal risk is that the Linux perf tool cannot access hardware counters under WSL or macOS. Our fallback is to use bare-metal cloud instances on AWS.</a:t>
             </a:r>
           </a:p>
           <a:p>
@@ -514,13 +466,19 @@
           <a:p>
             <a:r>
               <a:rPr lang="en-US" dirty="0"/>
-              <a:t>Closing question (then wait for an answer)</a:t>
-            </a:r>
-          </a:p>
-          <a:p>
-            <a:r>
-              <a:rPr lang="en-US" dirty="0"/>
-              <a:t>- Our question for the class is the following: for the remaining weeks, should we prioritize more real datasets, or insert-heavy workloads with ALEX?</a:t>
+              <a:t>Gate check and closing (0:20)</a:t>
+            </a:r>
+          </a:p>
+          <a:p>
+            <a:r>
+              <a:rPr lang="en-US" dirty="0"/>
+              <a:t>- Regarding the gate check, an incorrect prediction is safe, the labels are free, and the model is small. Whether the approach beats a tuned B+tree, and whether it withstands insert-heavy workloads, remains to be determined.</a:t>
+            </a:r>
+          </a:p>
+          <a:p>
+            <a:r>
+              <a:rPr lang="en-US" dirty="0"/>
+              <a:t>- We would like to close with a question for the class: should our next priority be additional real-world datasets, or insert-heavy workloads? Thank you.</a:t>
             </a:r>
           </a:p>
         </p:txBody>

</xml_diff>